<commit_message>
Add remote control layer + update TDA Insights, session data, and status files
</commit_message>
<xml_diff>
--- a/Store Support/Projects/TDA Insights/TDA_WK8_Report.pptx
+++ b/Store Support/Projects/TDA Insights/TDA_WK8_Report.pptx
@@ -3433,7 +3433,7 @@
         <p:spPr>
           <a:xfrm>
             <a:off x="0" y="0"/>
-            <a:ext cx="9144000" cy="6532815"/>
+            <a:ext cx="9144000" cy="6858000"/>
           </a:xfrm>
           <a:prstGeom prst="rect">
             <a:avLst/>
@@ -3517,7 +3517,7 @@
         <p:spPr>
           <a:xfrm>
             <a:off x="0" y="0"/>
-            <a:ext cx="9144000" cy="6858000"/>
+            <a:ext cx="9144000" cy="5926127"/>
           </a:xfrm>
           <a:prstGeom prst="rect">
             <a:avLst/>
@@ -3559,7 +3559,7 @@
         <p:spPr>
           <a:xfrm>
             <a:off x="0" y="0"/>
-            <a:ext cx="9144000" cy="2048178"/>
+            <a:ext cx="9144000" cy="5649477"/>
           </a:xfrm>
           <a:prstGeom prst="rect">
             <a:avLst/>
@@ -3643,7 +3643,7 @@
         <p:spPr>
           <a:xfrm>
             <a:off x="0" y="0"/>
-            <a:ext cx="9144000" cy="4766140"/>
+            <a:ext cx="9144000" cy="5037936"/>
           </a:xfrm>
           <a:prstGeom prst="rect">
             <a:avLst/>
@@ -3685,7 +3685,7 @@
         <p:spPr>
           <a:xfrm>
             <a:off x="0" y="0"/>
-            <a:ext cx="9144000" cy="6396917"/>
+            <a:ext cx="9144000" cy="6261019"/>
           </a:xfrm>
           <a:prstGeom prst="rect">
             <a:avLst/>
@@ -3769,7 +3769,7 @@
         <p:spPr>
           <a:xfrm>
             <a:off x="0" y="0"/>
-            <a:ext cx="9144000" cy="6430891"/>
+            <a:ext cx="9144000" cy="4596267"/>
           </a:xfrm>
           <a:prstGeom prst="rect">
             <a:avLst/>
@@ -3853,7 +3853,7 @@
         <p:spPr>
           <a:xfrm>
             <a:off x="0" y="0"/>
-            <a:ext cx="9144000" cy="6057171"/>
+            <a:ext cx="9144000" cy="6702687"/>
           </a:xfrm>
           <a:prstGeom prst="rect">
             <a:avLst/>
@@ -4021,7 +4021,7 @@
         <p:spPr>
           <a:xfrm>
             <a:off x="0" y="0"/>
-            <a:ext cx="9144000" cy="6858000"/>
+            <a:ext cx="9144000" cy="5921273"/>
           </a:xfrm>
           <a:prstGeom prst="rect">
             <a:avLst/>

</xml_diff>